<commit_message>
updated clean code for pre-commit hooks
</commit_message>
<xml_diff>
--- a/Python/Lesson 12 - Clean Code/Writing Clean Code.pptx
+++ b/Python/Lesson 12 - Clean Code/Writing Clean Code.pptx
@@ -216,7 +216,7 @@
           <a:p>
             <a:fld id="{ABAB54D4-40B1-4F4F-A71E-587F6353CB71}" type="datetimeFigureOut">
               <a:rPr lang="en-US" smtClean="0"/>
-              <a:t>02-Jun-26</a:t>
+              <a:t>8/7/2026</a:t>
             </a:fld>
             <a:endParaRPr lang="en-US"/>
           </a:p>
@@ -1071,7 +1071,7 @@
           <a:p>
             <a:fld id="{7A3E0868-4E26-4CDC-8A56-D70E2D8B12FE}" type="datetime3">
               <a:rPr lang="en-US" smtClean="0"/>
-              <a:t>2 June 2026</a:t>
+              <a:t>7 August 2026</a:t>
             </a:fld>
             <a:endParaRPr lang="en-US"/>
           </a:p>
@@ -3632,7 +3632,7 @@
           <a:p>
             <a:fld id="{A7B8021B-6105-4216-96FC-94348F216D0E}" type="datetime3">
               <a:rPr lang="en-US" smtClean="0"/>
-              <a:t>2 June 2026</a:t>
+              <a:t>7 August 2026</a:t>
             </a:fld>
             <a:endParaRPr lang="en-US"/>
           </a:p>
@@ -5329,7 +5329,7 @@
           <a:p>
             <a:fld id="{5D27CFAB-73E6-44A8-B862-B3306344E3F2}" type="datetime3">
               <a:rPr lang="en-US" smtClean="0"/>
-              <a:t>2 June 2026</a:t>
+              <a:t>7 August 2026</a:t>
             </a:fld>
             <a:endParaRPr lang="en-US"/>
           </a:p>
@@ -7119,7 +7119,7 @@
           <a:p>
             <a:fld id="{A9B2E784-A5F5-4301-881B-94AC8DBF9DED}" type="datetime3">
               <a:rPr lang="en-US" smtClean="0"/>
-              <a:t>2 June 2026</a:t>
+              <a:t>7 August 2026</a:t>
             </a:fld>
             <a:endParaRPr lang="en-US"/>
           </a:p>
@@ -7298,7 +7298,7 @@
           <a:p>
             <a:fld id="{18EAB3A5-9E92-4BB9-8F22-9632B4FBEDBA}" type="datetime3">
               <a:rPr lang="en-US" smtClean="0"/>
-              <a:t>2 June 2026</a:t>
+              <a:t>7 August 2026</a:t>
             </a:fld>
             <a:endParaRPr lang="en-US"/>
           </a:p>
@@ -7525,7 +7525,7 @@
           <a:p>
             <a:fld id="{40923810-5FB2-48C9-96CA-1DE2C4773142}" type="datetime3">
               <a:rPr lang="en-US" smtClean="0"/>
-              <a:t>2 June 2026</a:t>
+              <a:t>7 August 2026</a:t>
             </a:fld>
             <a:endParaRPr lang="en-US"/>
           </a:p>
@@ -7815,7 +7815,7 @@
           <a:p>
             <a:fld id="{E50EFF4B-86EB-42FB-93EA-7D8F9CB2466F}" type="datetime3">
               <a:rPr lang="en-US" smtClean="0"/>
-              <a:t>2 June 2026</a:t>
+              <a:t>7 August 2026</a:t>
             </a:fld>
             <a:endParaRPr lang="en-US"/>
           </a:p>
@@ -8427,7 +8427,7 @@
           <a:p>
             <a:fld id="{FB14FC24-E041-45E9-9A72-E5755A86890F}" type="datetime3">
               <a:rPr lang="en-US" smtClean="0"/>
-              <a:t>2 June 2026</a:t>
+              <a:t>7 August 2026</a:t>
             </a:fld>
             <a:endParaRPr lang="en-US"/>
           </a:p>
@@ -9287,7 +9287,7 @@
           <a:p>
             <a:fld id="{98A19125-94A7-4474-858C-FD9C4ABE9DDA}" type="datetime3">
               <a:rPr lang="en-US" smtClean="0"/>
-              <a:t>2 June 2026</a:t>
+              <a:t>7 August 2026</a:t>
             </a:fld>
             <a:endParaRPr lang="en-US"/>
           </a:p>
@@ -10390,7 +10390,7 @@
           <a:p>
             <a:fld id="{3BA0343D-C8D8-43CE-BB79-50DEA219DB07}" type="datetime3">
               <a:rPr lang="en-US" smtClean="0"/>
-              <a:t>2 June 2026</a:t>
+              <a:t>7 August 2026</a:t>
             </a:fld>
             <a:endParaRPr lang="en-US"/>
           </a:p>
@@ -10679,7 +10679,7 @@
           <a:p>
             <a:fld id="{453BD212-0B9F-4987-965F-AC83B2FC354F}" type="datetime3">
               <a:rPr lang="en-US" smtClean="0"/>
-              <a:t>2 June 2026</a:t>
+              <a:t>7 August 2026</a:t>
             </a:fld>
             <a:endParaRPr lang="en-US"/>
           </a:p>
@@ -10924,7 +10924,7 @@
           <a:p>
             <a:fld id="{6DDC931E-8CBE-4A3F-A034-9B6122C6DCDB}" type="datetime3">
               <a:rPr lang="en-US" smtClean="0"/>
-              <a:t>2 June 2026</a:t>
+              <a:t>7 August 2026</a:t>
             </a:fld>
             <a:endParaRPr lang="en-US"/>
           </a:p>
@@ -12690,7 +12690,7 @@
           <a:p>
             <a:fld id="{220AF9C2-5E8A-4308-AE6B-CA9B65007D0E}" type="datetime3">
               <a:rPr lang="en-US" smtClean="0"/>
-              <a:t>2 June 2026</a:t>
+              <a:t>7 August 2026</a:t>
             </a:fld>
             <a:endParaRPr lang="en-US"/>
           </a:p>
@@ -13003,7 +13003,7 @@
           <a:p>
             <a:fld id="{FF31E861-D2AF-431D-860B-DCF67C218052}" type="datetime3">
               <a:rPr lang="en-US" smtClean="0"/>
-              <a:t>2 June 2026</a:t>
+              <a:t>7 August 2026</a:t>
             </a:fld>
             <a:endParaRPr lang="en-US"/>
           </a:p>
@@ -13282,7 +13282,7 @@
           <a:p>
             <a:fld id="{D1DA25B2-AAF1-4C1F-AA38-12D5BFA7D4C8}" type="datetime3">
               <a:rPr lang="en-US" smtClean="0"/>
-              <a:t>2 June 2026</a:t>
+              <a:t>7 August 2026</a:t>
             </a:fld>
             <a:endParaRPr lang="en-US"/>
           </a:p>
@@ -13561,7 +13561,7 @@
           <a:p>
             <a:fld id="{A25C0F39-45D0-48E9-90B3-7FE8FCE561C8}" type="datetime3">
               <a:rPr lang="en-US" smtClean="0"/>
-              <a:t>2 June 2026</a:t>
+              <a:t>7 August 2026</a:t>
             </a:fld>
             <a:endParaRPr lang="en-US"/>
           </a:p>
@@ -14062,7 +14062,7 @@
           <a:p>
             <a:fld id="{9BAF1A3D-92FA-4F24-9781-74AFA516A230}" type="datetime3">
               <a:rPr lang="en-US" smtClean="0"/>
-              <a:t>2 June 2026</a:t>
+              <a:t>7 August 2026</a:t>
             </a:fld>
             <a:endParaRPr lang="en-US"/>
           </a:p>
@@ -14189,7 +14189,7 @@
           <a:p>
             <a:fld id="{5719C672-856D-4617-A693-8FE15749A9B7}" type="datetime3">
               <a:rPr lang="en-US" smtClean="0"/>
-              <a:t>2 June 2026</a:t>
+              <a:t>7 August 2026</a:t>
             </a:fld>
             <a:endParaRPr lang="en-US"/>
           </a:p>
@@ -14324,7 +14324,7 @@
           <a:p>
             <a:fld id="{5F6C764D-A39E-4C03-B161-E0BC66E8883B}" type="datetime3">
               <a:rPr lang="en-US" smtClean="0"/>
-              <a:t>2 June 2026</a:t>
+              <a:t>7 August 2026</a:t>
             </a:fld>
             <a:endParaRPr lang="en-US"/>
           </a:p>
@@ -14566,7 +14566,7 @@
           <a:p>
             <a:fld id="{6E3E33F9-20B7-4995-BE7D-165DBB597850}" type="datetime3">
               <a:rPr lang="en-US" smtClean="0"/>
-              <a:t>2 June 2026</a:t>
+              <a:t>7 August 2026</a:t>
             </a:fld>
             <a:endParaRPr lang="en-US"/>
           </a:p>
@@ -14679,7 +14679,7 @@
           <a:p>
             <a:fld id="{CD41C263-3501-4369-A962-62B6BF915CDE}" type="datetime3">
               <a:rPr lang="en-US" smtClean="0"/>
-              <a:t>2 June 2026</a:t>
+              <a:t>7 August 2026</a:t>
             </a:fld>
             <a:endParaRPr lang="en-US"/>
           </a:p>
@@ -15082,7 +15082,7 @@
           <a:p>
             <a:fld id="{B06F3EBE-B2E8-4992-9F00-9E4B44F057C0}" type="datetime3">
               <a:rPr lang="en-US" smtClean="0"/>
-              <a:t>2 June 2026</a:t>
+              <a:t>7 August 2026</a:t>
             </a:fld>
             <a:endParaRPr lang="en-US"/>
           </a:p>
@@ -15214,7 +15214,7 @@
           <a:p>
             <a:fld id="{D41656AB-D2E1-472E-8B95-0DF5C6E1D623}" type="datetime3">
               <a:rPr lang="en-US" smtClean="0"/>
-              <a:t>2 June 2026</a:t>
+              <a:t>7 August 2026</a:t>
             </a:fld>
             <a:endParaRPr lang="en-US"/>
           </a:p>
@@ -19410,7 +19410,7 @@
           <a:p>
             <a:fld id="{40BEADEB-7507-46CB-9ABE-86F6B40F8C4B}" type="datetimeFigureOut">
               <a:rPr lang="en-US" smtClean="0"/>
-              <a:t>02-Jun-26</a:t>
+              <a:t>8/7/2026</a:t>
             </a:fld>
             <a:endParaRPr lang="en-US"/>
           </a:p>
@@ -19675,7 +19675,7 @@
           <a:p>
             <a:fld id="{40BEADEB-7507-46CB-9ABE-86F6B40F8C4B}" type="datetimeFigureOut">
               <a:rPr lang="en-US" smtClean="0"/>
-              <a:t>02-Jun-26</a:t>
+              <a:t>8/7/2026</a:t>
             </a:fld>
             <a:endParaRPr lang="en-US"/>
           </a:p>
@@ -20087,7 +20087,7 @@
           <a:p>
             <a:fld id="{40BEADEB-7507-46CB-9ABE-86F6B40F8C4B}" type="datetimeFigureOut">
               <a:rPr lang="en-US" smtClean="0"/>
-              <a:t>02-Jun-26</a:t>
+              <a:t>8/7/2026</a:t>
             </a:fld>
             <a:endParaRPr lang="en-US"/>
           </a:p>
@@ -20283,7 +20283,7 @@
           <a:p>
             <a:fld id="{AD622D1A-DF83-41A8-85FF-04D90BF831D3}" type="datetime3">
               <a:rPr lang="en-US" smtClean="0"/>
-              <a:t>2 June 2026</a:t>
+              <a:t>7 August 2026</a:t>
             </a:fld>
             <a:endParaRPr lang="en-US"/>
           </a:p>
@@ -20533,7 +20533,7 @@
           <a:p>
             <a:fld id="{334F72C3-CDF3-44A8-B602-1649B1728485}" type="datetime3">
               <a:rPr lang="en-US" smtClean="0"/>
-              <a:t>2 June 2026</a:t>
+              <a:t>7 August 2026</a:t>
             </a:fld>
             <a:endParaRPr lang="en-US"/>
           </a:p>
@@ -20840,7 +20840,7 @@
           <a:p>
             <a:fld id="{1E0132BA-B5E7-4FFD-AF6C-169169D47D4A}" type="datetime3">
               <a:rPr lang="en-US" smtClean="0"/>
-              <a:t>2 June 2026</a:t>
+              <a:t>7 August 2026</a:t>
             </a:fld>
             <a:endParaRPr lang="en-US"/>
           </a:p>
@@ -21321,7 +21321,7 @@
           <a:p>
             <a:fld id="{81A30091-1C2A-4151-8D3C-D1E47A72615F}" type="datetime3">
               <a:rPr lang="en-US" smtClean="0"/>
-              <a:t>2 June 2026</a:t>
+              <a:t>7 August 2026</a:t>
             </a:fld>
             <a:endParaRPr lang="en-US"/>
           </a:p>
@@ -21958,7 +21958,7 @@
           <a:p>
             <a:fld id="{35D703CE-07B4-4C05-A488-B4566700621F}" type="datetime3">
               <a:rPr lang="en-US" smtClean="0"/>
-              <a:t>2 June 2026</a:t>
+              <a:t>7 August 2026</a:t>
             </a:fld>
             <a:endParaRPr lang="en-US"/>
           </a:p>
@@ -23016,7 +23016,7 @@
           <a:p>
             <a:fld id="{694BD61C-20BA-43AF-A21F-1DAFB3200099}" type="datetime3">
               <a:rPr lang="en-US" smtClean="0"/>
-              <a:t>2 June 2026</a:t>
+              <a:t>7 August 2026</a:t>
             </a:fld>
             <a:endParaRPr lang="en-US"/>
           </a:p>
@@ -23503,7 +23503,7 @@
           <a:p>
             <a:fld id="{CABCB1B0-B6E5-4DD1-BB55-95C076D6C0C8}" type="datetime3">
               <a:rPr lang="en-US" smtClean="0"/>
-              <a:t>2 June 2026</a:t>
+              <a:t>7 August 2026</a:t>
             </a:fld>
             <a:endParaRPr lang="en-US"/>
           </a:p>
@@ -25103,7 +25103,7 @@
           <a:p>
             <a:fld id="{090BF60B-FC76-43EF-A574-A47D8B93F449}" type="datetime1">
               <a:rPr lang="en-US" smtClean="0"/>
-              <a:t>02-Jun-26</a:t>
+              <a:t>8/7/2026</a:t>
             </a:fld>
             <a:endParaRPr lang="en-US"/>
           </a:p>
@@ -25283,7 +25283,7 @@
           <a:p>
             <a:fld id="{AD622D1A-DF83-41A8-85FF-04D90BF831D3}" type="datetime3">
               <a:rPr lang="en-US" smtClean="0"/>
-              <a:t>2 June 2026</a:t>
+              <a:t>7 August 2026</a:t>
             </a:fld>
             <a:endParaRPr lang="en-US"/>
           </a:p>
@@ -26501,7 +26501,7 @@
           <a:p>
             <a:fld id="{5CD7C113-A95A-4A67-9C34-D78403B0271D}" type="datetime1">
               <a:rPr lang="en-US" smtClean="0"/>
-              <a:t>02-Jun-26</a:t>
+              <a:t>8/7/2026</a:t>
             </a:fld>
             <a:endParaRPr lang="en-US"/>
           </a:p>
@@ -26533,6 +26533,52 @@
               <a:t>18</a:t>
             </a:fld>
             <a:endParaRPr lang="en-US"/>
+          </a:p>
+        </p:txBody>
+      </p:sp>
+      <p:sp>
+        <p:nvSpPr>
+          <p:cNvPr id="2" name="TextBox 1">
+            <a:extLst>
+              <a:ext uri="{FF2B5EF4-FFF2-40B4-BE49-F238E27FC236}">
+                <a16:creationId xmlns:a16="http://schemas.microsoft.com/office/drawing/2014/main" id="{4FB01D4A-CFBF-FB35-E310-E0197DA5ED28}"/>
+              </a:ext>
+            </a:extLst>
+          </p:cNvPr>
+          <p:cNvSpPr txBox="1"/>
+          <p:nvPr/>
+        </p:nvSpPr>
+        <p:spPr>
+          <a:xfrm>
+            <a:off x="631371" y="5529943"/>
+            <a:ext cx="3592286" cy="468086"/>
+          </a:xfrm>
+          <a:prstGeom prst="rect">
+            <a:avLst/>
+          </a:prstGeom>
+          <a:noFill/>
+        </p:spPr>
+        <p:txBody>
+          <a:bodyPr wrap="square" lIns="0" tIns="0" rIns="0" bIns="0" rtlCol="0">
+            <a:noAutofit/>
+          </a:bodyPr>
+          <a:lstStyle/>
+          <a:p>
+            <a:pPr marL="182880" indent="-182880">
+              <a:lnSpc>
+                <a:spcPct val="95000"/>
+              </a:lnSpc>
+              <a:spcBef>
+                <a:spcPts val="1000"/>
+              </a:spcBef>
+              <a:buSzPct val="100000"/>
+              <a:buFont typeface="Arial"/>
+              <a:buChar char="▪"/>
+            </a:pPr>
+            <a:r>
+              <a:rPr lang="en-US" sz="1700" dirty="0"/>
+              <a:t>Pre-commit hooks!</a:t>
+            </a:r>
           </a:p>
         </p:txBody>
       </p:sp>
@@ -26546,6 +26592,84 @@
   <p:clrMapOvr>
     <a:masterClrMapping/>
   </p:clrMapOvr>
+  <p:timing>
+    <p:tnLst>
+      <p:par>
+        <p:cTn id="1" dur="indefinite" restart="never" nodeType="tmRoot">
+          <p:childTnLst>
+            <p:seq concurrent="1" nextAc="seek">
+              <p:cTn id="2" dur="indefinite" nodeType="mainSeq">
+                <p:childTnLst>
+                  <p:par>
+                    <p:cTn id="3" fill="hold">
+                      <p:stCondLst>
+                        <p:cond delay="indefinite"/>
+                      </p:stCondLst>
+                      <p:childTnLst>
+                        <p:par>
+                          <p:cTn id="4" fill="hold">
+                            <p:stCondLst>
+                              <p:cond delay="0"/>
+                            </p:stCondLst>
+                            <p:childTnLst>
+                              <p:par>
+                                <p:cTn id="5" presetID="1" presetClass="entr" presetSubtype="0" fill="hold" grpId="0" nodeType="clickEffect">
+                                  <p:stCondLst>
+                                    <p:cond delay="0"/>
+                                  </p:stCondLst>
+                                  <p:childTnLst>
+                                    <p:set>
+                                      <p:cBhvr>
+                                        <p:cTn id="6" dur="1" fill="hold">
+                                          <p:stCondLst>
+                                            <p:cond delay="0"/>
+                                          </p:stCondLst>
+                                        </p:cTn>
+                                        <p:tgtEl>
+                                          <p:spTgt spid="2"/>
+                                        </p:tgtEl>
+                                        <p:attrNameLst>
+                                          <p:attrName>style.visibility</p:attrName>
+                                        </p:attrNameLst>
+                                      </p:cBhvr>
+                                      <p:to>
+                                        <p:strVal val="visible"/>
+                                      </p:to>
+                                    </p:set>
+                                  </p:childTnLst>
+                                </p:cTn>
+                              </p:par>
+                            </p:childTnLst>
+                          </p:cTn>
+                        </p:par>
+                      </p:childTnLst>
+                    </p:cTn>
+                  </p:par>
+                </p:childTnLst>
+              </p:cTn>
+              <p:prevCondLst>
+                <p:cond evt="onPrev" delay="0">
+                  <p:tgtEl>
+                    <p:sldTgt/>
+                  </p:tgtEl>
+                </p:cond>
+              </p:prevCondLst>
+              <p:nextCondLst>
+                <p:cond evt="onNext" delay="0">
+                  <p:tgtEl>
+                    <p:sldTgt/>
+                  </p:tgtEl>
+                </p:cond>
+              </p:nextCondLst>
+            </p:seq>
+          </p:childTnLst>
+        </p:cTn>
+      </p:par>
+    </p:tnLst>
+    <p:bldLst>
+      <p:bldP spid="2" grpId="0"/>
+    </p:bldLst>
+  </p:timing>
 </p:sld>
 </file>
 
@@ -26945,7 +27069,7 @@
           <a:p>
             <a:fld id="{AD622D1A-DF83-41A8-85FF-04D90BF831D3}" type="datetime3">
               <a:rPr lang="en-US" smtClean="0"/>
-              <a:t>2 June 2026</a:t>
+              <a:t>7 August 2026</a:t>
             </a:fld>
             <a:endParaRPr lang="en-US"/>
           </a:p>

</xml_diff>